<commit_message>
Add a PDF to Excel conversion tool for document processing
Implements a new PDF to Excel conversion feature, including frontend JavaScript, backend routing, and a Python conversion script utilizing PyMuPDF and openpyxl.

Replit-Commit-Author: Agent
Replit-Commit-Session-Id: 60da4e55-3e3e-4c14-a778-bc010fd00c2d
Replit-Commit-Checkpoint-Type: full_checkpoint
Replit-Commit-Screenshot-Url: https://storage.googleapis.com/screenshot-production-us-central1/35ecc3c8-b269-410e-ba9e-2756d5961cee/60da4e55-3e3e-4c14-a778-bc010fd00c2d/m4hrtoP
</commit_message>
<xml_diff>
--- a/downloads/converted_CoverLetter.pptx
+++ b/downloads/converted_CoverLetter.pptx
@@ -3122,30 +3122,266 @@
           <a:p/>
         </p:txBody>
       </p:sp>
-      <p:pic>
-        <p:nvPicPr>
-          <p:cNvPr id="4" name="Picture 3" descr="image.png"/>
-          <p:cNvPicPr>
-            <a:picLocks noChangeAspect="1"/>
-          </p:cNvPicPr>
+      <p:sp>
+        <p:nvSpPr>
+          <p:cNvPr id="4" name="TextBox 3"/>
+          <p:cNvSpPr txBox="1"/>
           <p:nvPr/>
-        </p:nvPicPr>
-        <p:blipFill>
-          <a:blip r:embed="rId2"/>
-          <a:stretch>
-            <a:fillRect/>
-          </a:stretch>
-        </p:blipFill>
+        </p:nvSpPr>
         <p:spPr>
           <a:xfrm>
             <a:off x="457200" y="457200"/>
-            <a:ext cx="8229600" cy="11626381"/>
+            <a:ext cx="8229600" cy="5943600"/>
           </a:xfrm>
           <a:prstGeom prst="rect">
             <a:avLst/>
           </a:prstGeom>
+          <a:noFill/>
         </p:spPr>
-      </p:pic>
+        <p:txBody>
+          <a:bodyPr wrap="square">
+            <a:spAutoFit/>
+          </a:bodyPr>
+          <a:lstStyle/>
+          <a:p>
+            <a:pPr>
+              <a:spcAft>
+                <a:spcPts val="600"/>
+              </a:spcAft>
+            </a:pPr>
+            <a:r>
+              <a:rPr sz="1200" b="0"/>
+              <a:t>Iqbal Basha Mohammad</a:t>
+            </a:r>
+          </a:p>
+          <a:p>
+            <a:pPr>
+              <a:spcAft>
+                <a:spcPts val="600"/>
+              </a:spcAft>
+            </a:pPr>
+            <a:r>
+              <a:rPr sz="1200" b="0"/>
+              <a:t>Bangalore, India</a:t>
+            </a:r>
+          </a:p>
+          <a:p>
+            <a:pPr>
+              <a:spcAft>
+                <a:spcPts val="600"/>
+              </a:spcAft>
+            </a:pPr>
+            <a:r>
+              <a:rPr sz="1200" b="0"/>
+              <a:t>📧 iqbalbashasi@gmail.com | 📞 +91-8904639583</a:t>
+            </a:r>
+          </a:p>
+          <a:p>
+            <a:pPr>
+              <a:spcAft>
+                <a:spcPts val="600"/>
+              </a:spcAft>
+            </a:pPr>
+            <a:r>
+              <a:rPr sz="1200" b="1"/>
+              <a:t>Hiring Manager</a:t>
+            </a:r>
+          </a:p>
+          <a:p>
+            <a:pPr>
+              <a:spcAft>
+                <a:spcPts val="600"/>
+              </a:spcAft>
+            </a:pPr>
+            <a:r>
+              <a:rPr sz="1200" b="0"/>
+              <a:t>CRH Group Services Ltd.</a:t>
+            </a:r>
+          </a:p>
+          <a:p>
+            <a:pPr>
+              <a:spcAft>
+                <a:spcPts val="600"/>
+              </a:spcAft>
+            </a:pPr>
+            <a:r>
+              <a:rPr sz="1200" b="0"/>
+              <a:t>Amsterdam, Netherlands</a:t>
+            </a:r>
+          </a:p>
+          <a:p>
+            <a:pPr>
+              <a:spcAft>
+                <a:spcPts val="600"/>
+              </a:spcAft>
+            </a:pPr>
+            <a:r>
+              <a:rPr sz="1200" b="1"/>
+              <a:t>Subject : Application for Microsoft 365 Platform Manager</a:t>
+            </a:r>
+          </a:p>
+          <a:p>
+            <a:pPr>
+              <a:spcAft>
+                <a:spcPts val="600"/>
+              </a:spcAft>
+            </a:pPr>
+            <a:r>
+              <a:rPr sz="1200" b="0"/>
+              <a:t>Dear Hiring Manager,</a:t>
+            </a:r>
+          </a:p>
+          <a:p>
+            <a:pPr>
+              <a:spcAft>
+                <a:spcPts val="600"/>
+              </a:spcAft>
+            </a:pPr>
+            <a:r>
+              <a:rPr sz="1200" b="0"/>
+              <a:t>I am writing to express my interest in the Microsoft 365 Platform Manager role at CRH. With</a:t>
+            </a:r>
+          </a:p>
+          <a:p>
+            <a:pPr>
+              <a:spcAft>
+                <a:spcPts val="600"/>
+              </a:spcAft>
+            </a:pPr>
+            <a:r>
+              <a:rPr sz="1200" b="0"/>
+              <a:t>18+ years in Microsoft 365, Power Platform, and SharePoint, I have led large-scale</a:t>
+            </a:r>
+          </a:p>
+          <a:p>
+            <a:pPr>
+              <a:spcAft>
+                <a:spcPts val="600"/>
+              </a:spcAft>
+            </a:pPr>
+            <a:r>
+              <a:rPr sz="1200" b="0"/>
+              <a:t>migrations and governance programs that improved collaboration, security, and compliance</a:t>
+            </a:r>
+          </a:p>
+          <a:p>
+            <a:pPr>
+              <a:spcAft>
+                <a:spcPts val="600"/>
+              </a:spcAft>
+            </a:pPr>
+            <a:r>
+              <a:rPr sz="1200" b="0"/>
+              <a:t>for global enterprises.</a:t>
+            </a:r>
+          </a:p>
+          <a:p>
+            <a:pPr>
+              <a:spcAft>
+                <a:spcPts val="600"/>
+              </a:spcAft>
+            </a:pPr>
+            <a:r>
+              <a:rPr sz="1200" b="0"/>
+              <a:t>At Microland, I recently managed a cross-tenant migration of 95,000+ users and 290 TB of</a:t>
+            </a:r>
+          </a:p>
+          <a:p>
+            <a:pPr>
+              <a:spcAft>
+                <a:spcPts val="600"/>
+              </a:spcAft>
+            </a:pPr>
+            <a:r>
+              <a:rPr sz="1200" b="0"/>
+              <a:t>data with minimal disruption. I also designed PowerApps and automated workflows that</a:t>
+            </a:r>
+          </a:p>
+          <a:p>
+            <a:pPr>
+              <a:spcAft>
+                <a:spcPts val="600"/>
+              </a:spcAft>
+            </a:pPr>
+            <a:r>
+              <a:rPr sz="1200" b="0"/>
+              <a:t>reduced manual tasks by 60% while ensuring governance and adoption across business</a:t>
+            </a:r>
+          </a:p>
+          <a:p>
+            <a:pPr>
+              <a:spcAft>
+                <a:spcPts val="600"/>
+              </a:spcAft>
+            </a:pPr>
+            <a:r>
+              <a:rPr sz="1200" b="0"/>
+              <a:t>units. These experiences align closely with your need to optimize Microsoft 365 services at a</a:t>
+            </a:r>
+          </a:p>
+          <a:p>
+            <a:pPr>
+              <a:spcAft>
+                <a:spcPts val="600"/>
+              </a:spcAft>
+            </a:pPr>
+            <a:r>
+              <a:rPr sz="1200" b="0"/>
+              <a:t>global level.</a:t>
+            </a:r>
+          </a:p>
+          <a:p>
+            <a:pPr>
+              <a:spcAft>
+                <a:spcPts val="600"/>
+              </a:spcAft>
+            </a:pPr>
+            <a:r>
+              <a:rPr sz="1200" b="0"/>
+              <a:t>I am inspired by CRH’s commitment to building a connected and sustainable digital</a:t>
+            </a:r>
+          </a:p>
+          <a:p>
+            <a:pPr>
+              <a:spcAft>
+                <a:spcPts val="600"/>
+              </a:spcAft>
+            </a:pPr>
+            <a:r>
+              <a:rPr sz="1200" b="0"/>
+              <a:t>workplace. I would welcome the chance to discuss how my expertise can support your</a:t>
+            </a:r>
+          </a:p>
+          <a:p>
+            <a:pPr>
+              <a:spcAft>
+                <a:spcPts val="600"/>
+              </a:spcAft>
+            </a:pPr>
+            <a:r>
+              <a:rPr sz="1200" b="0"/>
+              <a:t>Microsoft 365 roadmap and add value to the Central Technical Services team.</a:t>
+            </a:r>
+          </a:p>
+          <a:p>
+            <a:pPr>
+              <a:spcAft>
+                <a:spcPts val="600"/>
+              </a:spcAft>
+            </a:pPr>
+            <a:r>
+              <a:rPr sz="1200" b="0"/>
+              <a:t>Kind regards,</a:t>
+            </a:r>
+          </a:p>
+          <a:p>
+            <a:r>
+              <a:rPr sz="1200" b="1"/>
+              <a:t>Iqbal Basha Mohammad</a:t>
+            </a:r>
+          </a:p>
+        </p:txBody>
+      </p:sp>
     </p:spTree>
   </p:cSld>
   <p:clrMapOvr>

</xml_diff>